<commit_message>
feat(video): educator's bullet points beside the artwork in video slides
Video fragments showed only the AI artwork while the narration spoke
bullets nobody could see. When an image provider (not the text card)
produced the slide art and the slide has bullet points, the fragment is
now composed as: bullets on the left (drawn text), artwork on the right
— mirroring the enhanced-deck pptx layout. Disable with
settings.video.bullets_overlay: false.
</commit_message>
<xml_diff>
--- a/mascot-test/enhanced/test-deck.pptx
+++ b/mascot-test/enhanced/test-deck.pptx
@@ -503,7 +503,7 @@
           <a:lstStyle/>
           <a:p>
             <a:r>
-              <a:t>Coffee is practically the lifeblood of the tech world, providing developers everywhere with the sustained energy needed to tackle complex lines of code. Whether your personal preference is a concentrated espresso, a smooth filter, or refreshing cold brew, it’s that familiar caffeine kick that fuels creativity and focus during long coding sessions.</a:t>
+              <a:t>Now, let's talk about something synonymous with our industry: coffee. It is more than just a beverage; it provides the essential energy needed during deep work and long coding sessions. Whether you prefer an espresso shot, a filtered cup, or a cold brew, it remains a core staple of our daily routine.</a:t>
             </a:r>
           </a:p>
         </p:txBody>
@@ -573,7 +573,7 @@
           <a:lstStyle/>
           <a:p>
             <a:r>
-              <a:t>If coffee is known for its immediate jolt, tea serves as a much quieter alternative for those seeking sustained focus. Whether you prefer the vibrant earthiness of matcha, the sophisticated profile of oolong, or a classic earl grey, these varieties offer a more grounded and balanced way to begin your day.</a:t>
+              <a:t>If you’re looking for a gentler alternative to the quick jolt of coffee, tea offers a much steadier experience. Whether you prefer the earthy richness of matcha, the complex profile of an oolong, or the classic floral notes of an Earl Grey, it provides a calmer way to find your focus.</a:t>
             </a:r>
           </a:p>
         </p:txBody>

</xml_diff>